<commit_message>
presentation: final deck (team's Claude Design version + organizers' slides 7-11)
Co-Authored-By: Claude Opus 5.5 <noreply@anthropic.com>
Claude-Session: https://claude.ai/code/session_01KUsJ5WRJjWL4eSwB2Jbd6i
</commit_message>
<xml_diff>
--- a/presentation/Москоллектор_НейроКонтур_Защита.pptx
+++ b/presentation/Москоллектор_НейроКонтур_Защита.pptx
@@ -20,6 +20,7 @@
     <p:sldId id="268" r:id="rId19"/>
     <p:sldId id="269" r:id="rId20"/>
     <p:sldId id="270" r:id="rId21"/>
+    <p:sldId id="271" r:id="rId22"/>
   </p:sldIdLst>
   <p:sldSz cx="12192000" cy="6858000" type="screen4x3"/>
   <p:notesSz cx="6858000" cy="9144000"/>
@@ -3357,6 +3358,48 @@
       <p:pic>
         <p:nvPicPr>
           <p:cNvPr id="2" name="Picture 1" descr="hi-15.jpg"/>
+          <p:cNvPicPr>
+            <a:picLocks noChangeAspect="1"/>
+          </p:cNvPicPr>
+          <p:nvPr/>
+        </p:nvPicPr>
+        <p:blipFill>
+          <a:blip r:embed="rId2"/>
+          <a:stretch>
+            <a:fillRect/>
+          </a:stretch>
+        </p:blipFill>
+        <p:spPr>
+          <a:xfrm>
+            <a:off x="0" y="0"/>
+            <a:ext cx="12192000" cy="6858000"/>
+          </a:xfrm>
+          <a:prstGeom prst="rect">
+            <a:avLst/>
+          </a:prstGeom>
+        </p:spPr>
+      </p:pic>
+    </p:spTree>
+  </p:cSld>
+  <p:clrMapOvr>
+    <a:masterClrMapping/>
+  </p:clrMapOvr>
+</p:sld>
+</file>
+
+<file path=ppt/slides/slide16.xml><?xml version="1.0" encoding="utf-8"?>
+<p:sld xmlns:a="http://schemas.openxmlformats.org/drawingml/2006/main" xmlns:p="http://schemas.openxmlformats.org/presentationml/2006/main" xmlns:r="http://schemas.openxmlformats.org/officeDocument/2006/relationships">
+  <p:cSld>
+    <p:spTree>
+      <p:nvGrpSpPr>
+        <p:cNvPr id="1" name=""/>
+        <p:cNvGrpSpPr/>
+        <p:nvPr/>
+      </p:nvGrpSpPr>
+      <p:grpSpPr/>
+      <p:pic>
+        <p:nvPicPr>
+          <p:cNvPr id="2" name="Picture 1" descr="hi-16.jpg"/>
           <p:cNvPicPr>
             <a:picLocks noChangeAspect="1"/>
           </p:cNvPicPr>

</xml_diff>